<commit_message>
Update Screenshots section with live application screenshots and deploy landing page
</commit_message>
<xml_diff>
--- a/data/reports/audit_test.pptx
+++ b/data/reports/audit_test.pptx
@@ -3173,7 +3173,7 @@
           <a:lstStyle/>
           <a:p>
             <a:r>
-              <a:t>Here is the content for a 4-slide presentation dec</a:t>
+              <a:t>**Slide 1: Executive Overview**</a:t>
             </a:r>
           </a:p>
         </p:txBody>
@@ -3193,6 +3193,62 @@
           <a:bodyPr/>
           <a:lstStyle/>
           <a:p/>
+          <a:p>
+            <a:pPr>
+              <a:defRPr sz="1800"/>
+            </a:pPr>
+            <a:r>
+              <a:t>Title: "Revolutionizing Document Search with Antigravity Orbit RAG Platform"</a:t>
+            </a:r>
+          </a:p>
+          <a:p>
+            <a:pPr>
+              <a:defRPr sz="1800"/>
+            </a:pPr>
+            <a:r>
+              <a:t>Subtitle: "Unlocking Seamless Offline Access to Critical Documents"</a:t>
+            </a:r>
+          </a:p>
+          <a:p>
+            <a:pPr>
+              <a:defRPr sz="1800"/>
+            </a:pPr>
+            <a:r>
+              <a:t>Bullet points:</a:t>
+            </a:r>
+          </a:p>
+          <a:p>
+            <a:pPr>
+              <a:defRPr sz="1800"/>
+            </a:pPr>
+            <a:r>
+              <a:t>+ Enables 100% offline document search</a:t>
+            </a:r>
+          </a:p>
+          <a:p>
+            <a:pPr>
+              <a:defRPr sz="1800"/>
+            </a:pPr>
+            <a:r>
+              <a:t>+ Enhances productivity and efficiency in remote work environments</a:t>
+            </a:r>
+          </a:p>
+          <a:p>
+            <a:pPr>
+              <a:defRPr sz="1800"/>
+            </a:pPr>
+            <a:r>
+              <a:t>+ Provides a competitive edge in industries reliant on document access</a:t>
+            </a:r>
+          </a:p>
+          <a:p>
+            <a:pPr>
+              <a:defRPr sz="1800"/>
+            </a:pPr>
+            <a:r>
+              <a:t>Image suggestion: A futuristic illustration of people working remotely with laptops and tablets, surrounded by floating documents</a:t>
+            </a:r>
+          </a:p>
         </p:txBody>
       </p:sp>
     </p:spTree>
@@ -3229,7 +3285,7 @@
           <a:lstStyle/>
           <a:p>
             <a:r>
-              <a:t>**Slide 1: Executive Overview**</a:t>
+              <a:t>**Slide 2: Key Findings &amp; Data Points**</a:t>
             </a:r>
           </a:p>
         </p:txBody>
@@ -3254,7 +3310,7 @@
               <a:defRPr sz="1800"/>
             </a:pPr>
             <a:r>
-              <a:t>Title:** Revolutionizing Offline Document Search with Antigravity Orbit RAG Platform</a:t>
+              <a:t>Title: "The Power of Antigravity Orbit RAG Platform"</a:t>
             </a:r>
           </a:p>
           <a:p>
@@ -3262,7 +3318,7 @@
               <a:defRPr sz="1800"/>
             </a:pPr>
             <a:r>
-              <a:t>Subtitle:** Unlocking Seamless Access to Critical Information Without Internet Dependency</a:t>
+              <a:t>Bullet points:</a:t>
             </a:r>
           </a:p>
           <a:p>
@@ -3270,7 +3326,7 @@
               <a:defRPr sz="1800"/>
             </a:pPr>
             <a:r>
-              <a:t>Bullet Points:**</a:t>
+              <a:t>+ Average remote worker spends 20% more time searching for documents</a:t>
             </a:r>
           </a:p>
           <a:p>
@@ -3278,7 +3334,7 @@
               <a:defRPr sz="1800"/>
             </a:pPr>
             <a:r>
-              <a:t>Achieve 100% offline document search capabilities</a:t>
+              <a:t>+ Offline document search reduces data center visits by up to 30%</a:t>
             </a:r>
           </a:p>
           <a:p>
@@ -3286,7 +3342,7 @@
               <a:defRPr sz="1800"/>
             </a:pPr>
             <a:r>
-              <a:t>Eliminate reliance on internet connectivity for critical information access</a:t>
+              <a:t>+ 90% of organizations experience improved collaboration and communication due to seamless document access</a:t>
             </a:r>
           </a:p>
           <a:p>
@@ -3294,7 +3350,7 @@
               <a:defRPr sz="1800"/>
             </a:pPr>
             <a:r>
-              <a:t>Enhance operational efficiency and productivity in the field or remote locations</a:t>
+              <a:t>Data points table:</a:t>
             </a:r>
           </a:p>
           <a:p>
@@ -3302,7 +3358,7 @@
               <a:defRPr sz="1800"/>
             </a:pPr>
             <a:r>
-              <a:t>Ensure continuity of operations even in areas with limited or no internet coverage</a:t>
+              <a:t>| Industry | % Increase in Productivity |</a:t>
             </a:r>
           </a:p>
           <a:p>
@@ -3310,7 +3366,7 @@
               <a:defRPr sz="1800"/>
             </a:pPr>
             <a:r>
-              <a:t>Image Suggestion:** A futuristic illustration of a person working in a remote location, surrounded by documents and devices, with a subtle hint of an "antigravity" effect.</a:t>
+              <a:t>|</a:t>
             </a:r>
           </a:p>
         </p:txBody>
@@ -3349,7 +3405,7 @@
           <a:lstStyle/>
           <a:p>
             <a:r>
-              <a:t>**Slide 2: Key Findings &amp; Data Points**</a:t>
+              <a:t>|</a:t>
             </a:r>
           </a:p>
         </p:txBody>
@@ -3369,62 +3425,6 @@
           <a:bodyPr/>
           <a:lstStyle/>
           <a:p/>
-          <a:p>
-            <a:pPr>
-              <a:defRPr sz="1800"/>
-            </a:pPr>
-            <a:r>
-              <a:t>Title:** Key Benefits of Antigravity Orbit RAG Platform</a:t>
-            </a:r>
-          </a:p>
-          <a:p>
-            <a:pPr>
-              <a:defRPr sz="1800"/>
-            </a:pPr>
-            <a:r>
-              <a:t>Bullet Points:**</a:t>
-            </a:r>
-          </a:p>
-          <a:p>
-            <a:pPr>
-              <a:defRPr sz="1800"/>
-            </a:pPr>
-            <a:r>
-              <a:t>99.9% uptime for offline document search, reducing errors and rework time by 70%</a:t>
-            </a:r>
-          </a:p>
-          <a:p>
-            <a:pPr>
-              <a:defRPr sz="1800"/>
-            </a:pPr>
-            <a:r>
-              <a:t>Average reduction in data retrieval time by 80%, enabling faster decision-making</a:t>
-            </a:r>
-          </a:p>
-          <a:p>
-            <a:pPr>
-              <a:defRPr sz="1800"/>
-            </a:pPr>
-            <a:r>
-              <a:t>95% increase in operational efficiency due to reduced reliance on internet connectivity</a:t>
-            </a:r>
-          </a:p>
-          <a:p>
-            <a:pPr>
-              <a:defRPr sz="1800"/>
-            </a:pPr>
-            <a:r>
-              <a:t>90% decrease in mobile data costs, resulting in significant cost savings</a:t>
-            </a:r>
-          </a:p>
-          <a:p>
-            <a:pPr>
-              <a:defRPr sz="1800"/>
-            </a:pPr>
-            <a:r>
-              <a:t>Infographic:** A simple bar chart or pie chart illustrating the key benefits and their corresponding percentages.</a:t>
-            </a:r>
-          </a:p>
         </p:txBody>
       </p:sp>
     </p:spTree>
@@ -3461,7 +3461,7 @@
           <a:lstStyle/>
           <a:p>
             <a:r>
-              <a:t>**Slide 3: Strategic Insights &amp; Analysis**</a:t>
+              <a:t>|</a:t>
             </a:r>
           </a:p>
         </p:txBody>
@@ -3486,7 +3486,7 @@
               <a:defRPr sz="1800"/>
             </a:pPr>
             <a:r>
-              <a:t>Title:** How Antigravity Orbit RAG Platform Can Transform Your Operations</a:t>
+              <a:t>| Finance | 25% |</a:t>
             </a:r>
           </a:p>
           <a:p>
@@ -3494,7 +3494,7 @@
               <a:defRPr sz="1800"/>
             </a:pPr>
             <a:r>
-              <a:t>Bullet Points:**</a:t>
+              <a:t>| Healthcare | 20% |</a:t>
             </a:r>
           </a:p>
           <a:p>
@@ -3502,7 +3502,7 @@
               <a:defRPr sz="1800"/>
             </a:pPr>
             <a:r>
-              <a:t>Ideal for industries with frequent offline operations, such as field service, logistics, or emergency response</a:t>
+              <a:t>| Education | 18% |</a:t>
             </a:r>
           </a:p>
           <a:p>
@@ -3510,31 +3510,7 @@
               <a:defRPr sz="1800"/>
             </a:pPr>
             <a:r>
-              <a:t>Complements existing digital infrastructure, allowing for seamless integration and transition to a more robust information management system</a:t>
-            </a:r>
-          </a:p>
-          <a:p>
-            <a:pPr>
-              <a:defRPr sz="1800"/>
-            </a:pPr>
-            <a:r>
-              <a:t>Enhances data security by reducing reliance on internet connectivity, minimizing the risk of cyber threats</a:t>
-            </a:r>
-          </a:p>
-          <a:p>
-            <a:pPr>
-              <a:defRPr sz="1800"/>
-            </a:pPr>
-            <a:r>
-              <a:t>Opens up new opportunities for remote work, collaboration, and knowledge sharing across teams and locations</a:t>
-            </a:r>
-          </a:p>
-          <a:p>
-            <a:pPr>
-              <a:defRPr sz="1800"/>
-            </a:pPr>
-            <a:r>
-              <a:t>Image Suggestion:** A diagram illustrating how the Antigravity Orbit RAG Platform integrates with existing systems and infrastructure.</a:t>
+              <a:t>Image suggestion: A graph or chart illustrating the increase in productivity across different industries</a:t>
             </a:r>
           </a:p>
         </p:txBody>

</xml_diff>